<commit_message>
docs: update adviser to Ellen F. Mangaoang, MIT and instructor to Shekiro R. Raposas — all builders, slides, letters, manuscript, guides
</commit_message>
<xml_diff>
--- a/docs/manuscript/output/SmartSpend_Defense_Slides.pptx
+++ b/docs/manuscript/output/SmartSpend_Defense_Slides.pptx
@@ -3438,7 +3438,7 @@
                 </a:solidFill>
                 <a:latin typeface="Calibri"/>
               </a:rPr>
-              <a:t>Adviser: Janelli M. Mendez, DIT</a:t>
+              <a:t>Adviser: Ellen F. Mangaoang, MIT</a:t>
             </a:r>
           </a:p>
         </p:txBody>
@@ -16796,7 +16796,7 @@
                 </a:solidFill>
                 <a:latin typeface="Calibri"/>
               </a:rPr>
-              <a:t>Adviser: Janelli M. Mendez, DIT</a:t>
+              <a:t>Adviser: Ellen F. Mangaoang, MIT</a:t>
             </a:r>
           </a:p>
         </p:txBody>

</xml_diff>